<commit_message>
Surface the ML methodology already in the code on the midterm slides
The deck named the two models but not the discipline behind them, and the LLM
adjudication step had no slide at all despite "AI-Driven" being in the title.
All of this is implemented; none of it was visible to a reviewer.

Folded into existing slides rather than added as new ones -- the deck is already
at 16:

  linkage    the LLM adjudication of the review-tier band a threshold cannot settle
  tiers      Jenks named as the 1-D k-means it is
  supervised 80/20 held-out split, fixed seed, permutation importance, test-set metrics
  clustering k chosen by gap statistic, cross-checked against silhouette, k-means vs
             hierarchical compared by adjusted Rand index
  three-layer why the tier is not itself trained: no ground-truth label exists, and
             inventing one would make the model unfalsifiable

Co-Authored-By: Claude Opus 5 (1M context) <noreply@anthropic.com>
</commit_message>
<xml_diff>
--- a/docs/MSDS_498_Midterm.pptx
+++ b/docs/MSDS_498_Midterm.pptx
@@ -5115,7 +5115,26 @@
                 </a:solidFill>
                 <a:latin typeface="Arial"/>
               </a:rPr>
-              <a:t>-  Design: gradient boosting + linear; grad rate ~ opportunity, SES-controlled (Adelman; Reardon).</a:t>
+              <a:t>-  Design: HistGradientBoosting + linear baseline; grad rate ~ opportunity, SES-controlled (Adelman; Reardon).</a:t>
+            </a:r>
+          </a:p>
+          <a:p>
+            <a:pPr>
+              <a:lnSpc>
+                <a:spcPct val="105000"/>
+              </a:lnSpc>
+              <a:spcAft>
+                <a:spcPts val="900"/>
+              </a:spcAft>
+            </a:pPr>
+            <a:r>
+              <a:rPr sz="1550" b="0">
+                <a:solidFill>
+                  <a:srgbClr val="1A1A1A"/>
+                </a:solidFill>
+                <a:latin typeface="Arial"/>
+              </a:rPr>
+              <a:t>-  Discipline: 80/20 held-out split, fixed seed, permutation importance (10 repeats), R²/RMSE on the test set.</a:t>
             </a:r>
           </a:p>
           <a:p>
@@ -5290,7 +5309,26 @@
                 </a:solidFill>
                 <a:latin typeface="Arial"/>
               </a:rPr>
-              <a:t>-  K-means (k=4) + hierarchical over PCA components; region, academic profile, funding.</a:t>
+              <a:t>-  K-means + hierarchical over PCA components (90% variance retained); region, academic profile, funding.</a:t>
+            </a:r>
+          </a:p>
+          <a:p>
+            <a:pPr>
+              <a:lnSpc>
+                <a:spcPct val="105000"/>
+              </a:lnSpc>
+              <a:spcAft>
+                <a:spcPts val="900"/>
+              </a:spcAft>
+            </a:pPr>
+            <a:r>
+              <a:rPr sz="1550" b="0">
+                <a:solidFill>
+                  <a:srgbClr val="1A1A1A"/>
+                </a:solidFill>
+                <a:latin typeface="Arial"/>
+              </a:rPr>
+              <a:t>-  k=4 selected by gap statistic (Tibshirani et al., 2001), cross-checked against silhouette; the two algorithms compared by adjusted Rand index.</a:t>
             </a:r>
           </a:p>
           <a:p>
@@ -5498,7 +5536,26 @@
                 </a:solidFill>
                 <a:latin typeface="Arial"/>
               </a:rPr>
-              <a:t>-  Rationale: no ground-truth rigor label exists — so an auditable index, validated by ML.</a:t>
+              <a:t>-  Why not train the tier directly: no ground-truth rigor label exists anywhere — inventing one would make the model unfalsifiable.</a:t>
+            </a:r>
+          </a:p>
+          <a:p>
+            <a:pPr>
+              <a:lnSpc>
+                <a:spcPct val="105000"/>
+              </a:lnSpc>
+              <a:spcAft>
+                <a:spcPts val="900"/>
+              </a:spcAft>
+            </a:pPr>
+            <a:r>
+              <a:rPr sz="1550" b="0">
+                <a:solidFill>
+                  <a:srgbClr val="1A1A1A"/>
+                </a:solidFill>
+                <a:latin typeface="Arial"/>
+              </a:rPr>
+              <a:t>-  So: an auditable measurement instrument, validated by ML rather than produced by it.</a:t>
             </a:r>
           </a:p>
         </p:txBody>
@@ -6320,6 +6377,25 @@
                 </a:solidFill>
                 <a:latin typeface="Arial"/>
               </a:rPr>
+              <a:t>-  Ambiguous middle band: an LLM adjudicates the review-tier pairs a threshold cannot settle — each decision logged and auditable.</a:t>
+            </a:r>
+          </a:p>
+          <a:p>
+            <a:pPr>
+              <a:lnSpc>
+                <a:spcPct val="105000"/>
+              </a:lnSpc>
+              <a:spcAft>
+                <a:spcPts val="900"/>
+              </a:spcAft>
+            </a:pPr>
+            <a:r>
+              <a:rPr sz="1550" b="0">
+                <a:solidFill>
+                  <a:srgbClr val="1A1A1A"/>
+                </a:solidFill>
+                <a:latin typeface="Arial"/>
+              </a:rPr>
               <a:t>-  Reporting: match rates reported as a matter of course.</a:t>
             </a:r>
           </a:p>
@@ -6788,7 +6864,7 @@
                 </a:solidFill>
                 <a:latin typeface="Arial"/>
               </a:rPr>
-              <a:t>-  Method: Jenks natural breaks (Jenks, 1967; Fisher, 1958) — cuts at gaps in the distribution.</a:t>
+              <a:t>-  Method: Jenks natural breaks (Jenks, 1967; Fisher, 1958) — 1-D k-means, cutting at gaps in the distribution.</a:t>
             </a:r>
           </a:p>
           <a:p>

</xml_diff>